<commit_message>
changed the logos to include TUMCREATE
</commit_message>
<xml_diff>
--- a/slides_pptx/2024.06.07_Slides.pptx
+++ b/slides_pptx/2024.06.07_Slides.pptx
@@ -251,7 +251,7 @@
               <a:rPr lang="en-US" smtClean="0">
                 <a:latin typeface="Arial" panose="020B0604020202020204" pitchFamily="34" charset="0"/>
               </a:rPr>
-              <a:t>6/7/24</a:t>
+              <a:t>6/17/24</a:t>
             </a:fld>
             <a:endParaRPr lang="en-US" dirty="0">
               <a:latin typeface="Arial" panose="020B0604020202020204" pitchFamily="34" charset="0"/>
@@ -429,7 +429,7 @@
             <a:fld id="{0DF9DF7B-F6DF-4040-BF00-4447D75AE71E}" type="datetimeFigureOut">
               <a:rPr lang="en-US" smtClean="0"/>
               <a:pPr/>
-              <a:t>6/7/24</a:t>
+              <a:t>6/17/24</a:t>
             </a:fld>
             <a:endParaRPr lang="en-US" dirty="0"/>
           </a:p>
@@ -3225,6 +3225,35 @@
           </a:prstGeom>
         </p:spPr>
       </p:pic>
+      <p:pic>
+        <p:nvPicPr>
+          <p:cNvPr id="6" name="Grafik 5">
+            <a:extLst>
+              <a:ext uri="{FF2B5EF4-FFF2-40B4-BE49-F238E27FC236}">
+                <a16:creationId xmlns:a16="http://schemas.microsoft.com/office/drawing/2014/main" id="{D0867BE1-3D84-126F-9D5E-0401370A5E64}"/>
+              </a:ext>
+            </a:extLst>
+          </p:cNvPr>
+          <p:cNvPicPr>
+            <a:picLocks noChangeAspect="1"/>
+          </p:cNvPicPr>
+          <p:nvPr userDrawn="1"/>
+        </p:nvPicPr>
+        <p:blipFill rotWithShape="1">
+          <a:blip r:embed="rId9"/>
+          <a:srcRect l="41374" t="72783" r="41941" b="6505"/>
+          <a:stretch/>
+        </p:blipFill>
+        <p:spPr>
+          <a:xfrm>
+            <a:off x="2260608" y="5209064"/>
+            <a:ext cx="1430969" cy="336333"/>
+          </a:xfrm>
+          <a:prstGeom prst="rect">
+            <a:avLst/>
+          </a:prstGeom>
+        </p:spPr>
+      </p:pic>
     </p:spTree>
     <p:extLst>
       <p:ext uri="{BB962C8B-B14F-4D97-AF65-F5344CB8AC3E}">
@@ -4621,6 +4650,35 @@
           </a:prstGeom>
         </p:spPr>
       </p:pic>
+      <p:pic>
+        <p:nvPicPr>
+          <p:cNvPr id="12" name="Grafik 11">
+            <a:extLst>
+              <a:ext uri="{FF2B5EF4-FFF2-40B4-BE49-F238E27FC236}">
+                <a16:creationId xmlns:a16="http://schemas.microsoft.com/office/drawing/2014/main" id="{88FC44CF-B163-49E0-4DE8-56D83196720D}"/>
+              </a:ext>
+            </a:extLst>
+          </p:cNvPr>
+          <p:cNvPicPr>
+            <a:picLocks noChangeAspect="1"/>
+          </p:cNvPicPr>
+          <p:nvPr userDrawn="1"/>
+        </p:nvPicPr>
+        <p:blipFill rotWithShape="1">
+          <a:blip r:embed="rId9"/>
+          <a:srcRect l="41374" t="72783" r="41941" b="6505"/>
+          <a:stretch/>
+        </p:blipFill>
+        <p:spPr>
+          <a:xfrm>
+            <a:off x="2260608" y="5209064"/>
+            <a:ext cx="1430969" cy="336333"/>
+          </a:xfrm>
+          <a:prstGeom prst="rect">
+            <a:avLst/>
+          </a:prstGeom>
+        </p:spPr>
+      </p:pic>
     </p:spTree>
     <p:extLst>
       <p:ext uri="{BB962C8B-B14F-4D97-AF65-F5344CB8AC3E}">
@@ -7634,10 +7692,10 @@
       </p:grpSpPr>
       <p:pic>
         <p:nvPicPr>
-          <p:cNvPr id="15" name="Picture 14">
-            <a:extLst>
-              <a:ext uri="{FF2B5EF4-FFF2-40B4-BE49-F238E27FC236}">
-                <a16:creationId xmlns:a16="http://schemas.microsoft.com/office/drawing/2014/main" id="{3E7AFEBE-EB96-B5BE-E9E2-39426ECA7ED4}"/>
+          <p:cNvPr id="7" name="Grafik 6" descr="Ein Bild, das Screenshot, Kreis, Schrift enthält.&#10;&#10;Automatisch generierte Beschreibung">
+            <a:extLst>
+              <a:ext uri="{FF2B5EF4-FFF2-40B4-BE49-F238E27FC236}">
+                <a16:creationId xmlns:a16="http://schemas.microsoft.com/office/drawing/2014/main" id="{FE1A6724-6901-7EB1-969A-1D51DEEFD56D}"/>
               </a:ext>
             </a:extLst>
           </p:cNvPr>
@@ -7646,7 +7704,7 @@
           </p:cNvPicPr>
           <p:nvPr userDrawn="1"/>
         </p:nvPicPr>
-        <p:blipFill rotWithShape="1">
+        <p:blipFill>
           <a:blip r:embed="rId13">
             <a:extLst>
               <a:ext uri="{28A0092B-C50C-407E-A947-70E740481C1C}">
@@ -7654,128 +7712,26 @@
               </a:ext>
             </a:extLst>
           </a:blip>
-          <a:srcRect b="65948"/>
-          <a:stretch/>
+          <a:stretch>
+            <a:fillRect/>
+          </a:stretch>
         </p:blipFill>
         <p:spPr>
           <a:xfrm>
-            <a:off x="0" y="1"/>
-            <a:ext cx="12192000" cy="1006996"/>
+            <a:off x="154188" y="6278791"/>
+            <a:ext cx="1647015" cy="311840"/>
           </a:xfrm>
           <a:prstGeom prst="rect">
             <a:avLst/>
           </a:prstGeom>
         </p:spPr>
       </p:pic>
-      <p:sp>
-        <p:nvSpPr>
-          <p:cNvPr id="2" name="Title Placeholder 1">
-            <a:extLst>
-              <a:ext uri="{FF2B5EF4-FFF2-40B4-BE49-F238E27FC236}">
-                <a16:creationId xmlns:a16="http://schemas.microsoft.com/office/drawing/2014/main" id="{2BD6E141-F77C-4187-5327-AC654B5F85E8}"/>
-              </a:ext>
-            </a:extLst>
-          </p:cNvPr>
-          <p:cNvSpPr>
-            <a:spLocks noGrp="1"/>
-          </p:cNvSpPr>
-          <p:nvPr>
-            <p:ph type="title"/>
-          </p:nvPr>
-        </p:nvSpPr>
-        <p:spPr>
-          <a:xfrm>
-            <a:off x="156000" y="129472"/>
-            <a:ext cx="11880000" cy="793638"/>
-          </a:xfrm>
-          <a:prstGeom prst="rect">
-            <a:avLst/>
-          </a:prstGeom>
-        </p:spPr>
-        <p:txBody>
-          <a:bodyPr vert="horz" lIns="91440" tIns="45720" rIns="91440" bIns="45720" rtlCol="0" anchor="t" anchorCtr="0">
-            <a:noAutofit/>
-          </a:bodyPr>
-          <a:lstStyle/>
-          <a:p>
-            <a:endParaRPr lang="en-DE" dirty="0"/>
-          </a:p>
-        </p:txBody>
-      </p:sp>
-      <p:sp>
-        <p:nvSpPr>
-          <p:cNvPr id="3" name="Text Placeholder 2">
-            <a:extLst>
-              <a:ext uri="{FF2B5EF4-FFF2-40B4-BE49-F238E27FC236}">
-                <a16:creationId xmlns:a16="http://schemas.microsoft.com/office/drawing/2014/main" id="{6D438802-D82A-3EE8-3611-AD0007BD0F25}"/>
-              </a:ext>
-            </a:extLst>
-          </p:cNvPr>
-          <p:cNvSpPr>
-            <a:spLocks noGrp="1"/>
-          </p:cNvSpPr>
-          <p:nvPr>
-            <p:ph type="body" idx="1"/>
-          </p:nvPr>
-        </p:nvSpPr>
-        <p:spPr>
-          <a:xfrm>
-            <a:off x="156000" y="1129438"/>
-            <a:ext cx="11880000" cy="4975271"/>
-          </a:xfrm>
-          <a:prstGeom prst="rect">
-            <a:avLst/>
-          </a:prstGeom>
-        </p:spPr>
-        <p:txBody>
-          <a:bodyPr vert="horz" lIns="91440" tIns="45720" rIns="91440" bIns="45720" rtlCol="0">
-            <a:normAutofit/>
-          </a:bodyPr>
-          <a:lstStyle/>
-          <a:p>
-            <a:pPr lvl="0"/>
-            <a:r>
-              <a:rPr lang="en-GB" dirty="0"/>
-              <a:t>Click to edit Master text styles</a:t>
-            </a:r>
-          </a:p>
-          <a:p>
-            <a:pPr lvl="1"/>
-            <a:r>
-              <a:rPr lang="en-GB" dirty="0"/>
-              <a:t>Second level</a:t>
-            </a:r>
-          </a:p>
-          <a:p>
-            <a:pPr lvl="2"/>
-            <a:r>
-              <a:rPr lang="en-GB" dirty="0"/>
-              <a:t>Third level</a:t>
-            </a:r>
-          </a:p>
-          <a:p>
-            <a:pPr lvl="3"/>
-            <a:r>
-              <a:rPr lang="en-GB" dirty="0"/>
-              <a:t>Fourth level</a:t>
-            </a:r>
-          </a:p>
-          <a:p>
-            <a:pPr lvl="4"/>
-            <a:r>
-              <a:rPr lang="en-GB" dirty="0"/>
-              <a:t>Fifth level</a:t>
-            </a:r>
-            <a:endParaRPr lang="en-DE" dirty="0"/>
-          </a:p>
-        </p:txBody>
-      </p:sp>
       <p:pic>
         <p:nvPicPr>
-          <p:cNvPr id="8" name="Picture Placeholder 38">
-            <a:extLst>
-              <a:ext uri="{FF2B5EF4-FFF2-40B4-BE49-F238E27FC236}">
-                <a16:creationId xmlns:a16="http://schemas.microsoft.com/office/drawing/2014/main" id="{6C5153D8-994A-9B62-15B4-8947E5C60D80}"/>
+          <p:cNvPr id="15" name="Picture 14">
+            <a:extLst>
+              <a:ext uri="{FF2B5EF4-FFF2-40B4-BE49-F238E27FC236}">
+                <a16:creationId xmlns:a16="http://schemas.microsoft.com/office/drawing/2014/main" id="{3E7AFEBE-EB96-B5BE-E9E2-39426ECA7ED4}"/>
               </a:ext>
             </a:extLst>
           </p:cNvPr>
@@ -7792,64 +7748,128 @@
               </a:ext>
             </a:extLst>
           </a:blip>
-          <a:srcRect l="-2849" t="-16744" r="-6480" b="-29367"/>
+          <a:srcRect b="65948"/>
           <a:stretch/>
         </p:blipFill>
         <p:spPr>
           <a:xfrm>
-            <a:off x="105877" y="6225116"/>
-            <a:ext cx="1805988" cy="456974"/>
+            <a:off x="0" y="1"/>
+            <a:ext cx="12192000" cy="1006996"/>
           </a:xfrm>
           <a:prstGeom prst="rect">
             <a:avLst/>
           </a:prstGeom>
         </p:spPr>
       </p:pic>
-      <p:pic>
-        <p:nvPicPr>
-          <p:cNvPr id="9" name="Graphic 8">
-            <a:extLst>
-              <a:ext uri="{FF2B5EF4-FFF2-40B4-BE49-F238E27FC236}">
-                <a16:creationId xmlns:a16="http://schemas.microsoft.com/office/drawing/2014/main" id="{C7D08E24-258B-A058-315A-69B21A80CFDA}"/>
-              </a:ext>
-            </a:extLst>
-          </p:cNvPr>
-          <p:cNvPicPr>
-            <a:picLocks noChangeAspect="1"/>
-          </p:cNvPicPr>
-          <p:nvPr userDrawn="1"/>
-        </p:nvPicPr>
-        <p:blipFill>
-          <a:blip r:embed="rId15" cstate="print">
-            <a:extLst>
-              <a:ext uri="{28A0092B-C50C-407E-A947-70E740481C1C}">
-                <a14:useLocalDpi xmlns:a14="http://schemas.microsoft.com/office/drawing/2010/main" val="0"/>
-              </a:ext>
-              <a:ext uri="{96DAC541-7B7A-43D3-8B79-37D633B846F1}">
-                <asvg:svgBlip xmlns:asvg="http://schemas.microsoft.com/office/drawing/2016/SVG/main" r:embed="rId16"/>
-              </a:ext>
-            </a:extLst>
-          </a:blip>
-          <a:stretch>
-            <a:fillRect/>
-          </a:stretch>
-        </p:blipFill>
-        <p:spPr>
-          <a:xfrm>
-            <a:off x="2568014" y="6289144"/>
-            <a:ext cx="426729" cy="267538"/>
+      <p:sp>
+        <p:nvSpPr>
+          <p:cNvPr id="2" name="Title Placeholder 1">
+            <a:extLst>
+              <a:ext uri="{FF2B5EF4-FFF2-40B4-BE49-F238E27FC236}">
+                <a16:creationId xmlns:a16="http://schemas.microsoft.com/office/drawing/2014/main" id="{2BD6E141-F77C-4187-5327-AC654B5F85E8}"/>
+              </a:ext>
+            </a:extLst>
+          </p:cNvPr>
+          <p:cNvSpPr>
+            <a:spLocks noGrp="1"/>
+          </p:cNvSpPr>
+          <p:nvPr>
+            <p:ph type="title"/>
+          </p:nvPr>
+        </p:nvSpPr>
+        <p:spPr>
+          <a:xfrm>
+            <a:off x="156000" y="129472"/>
+            <a:ext cx="11880000" cy="793638"/>
           </a:xfrm>
           <a:prstGeom prst="rect">
             <a:avLst/>
           </a:prstGeom>
         </p:spPr>
-      </p:pic>
+        <p:txBody>
+          <a:bodyPr vert="horz" lIns="91440" tIns="45720" rIns="91440" bIns="45720" rtlCol="0" anchor="t" anchorCtr="0">
+            <a:noAutofit/>
+          </a:bodyPr>
+          <a:lstStyle/>
+          <a:p>
+            <a:endParaRPr lang="en-DE" dirty="0"/>
+          </a:p>
+        </p:txBody>
+      </p:sp>
+      <p:sp>
+        <p:nvSpPr>
+          <p:cNvPr id="3" name="Text Placeholder 2">
+            <a:extLst>
+              <a:ext uri="{FF2B5EF4-FFF2-40B4-BE49-F238E27FC236}">
+                <a16:creationId xmlns:a16="http://schemas.microsoft.com/office/drawing/2014/main" id="{6D438802-D82A-3EE8-3611-AD0007BD0F25}"/>
+              </a:ext>
+            </a:extLst>
+          </p:cNvPr>
+          <p:cNvSpPr>
+            <a:spLocks noGrp="1"/>
+          </p:cNvSpPr>
+          <p:nvPr>
+            <p:ph type="body" idx="1"/>
+          </p:nvPr>
+        </p:nvSpPr>
+        <p:spPr>
+          <a:xfrm>
+            <a:off x="156000" y="1129438"/>
+            <a:ext cx="11880000" cy="4975271"/>
+          </a:xfrm>
+          <a:prstGeom prst="rect">
+            <a:avLst/>
+          </a:prstGeom>
+        </p:spPr>
+        <p:txBody>
+          <a:bodyPr vert="horz" lIns="91440" tIns="45720" rIns="91440" bIns="45720" rtlCol="0">
+            <a:normAutofit/>
+          </a:bodyPr>
+          <a:lstStyle/>
+          <a:p>
+            <a:pPr lvl="0"/>
+            <a:r>
+              <a:rPr lang="en-GB" dirty="0"/>
+              <a:t>Click to edit Master text styles</a:t>
+            </a:r>
+          </a:p>
+          <a:p>
+            <a:pPr lvl="1"/>
+            <a:r>
+              <a:rPr lang="en-GB" dirty="0"/>
+              <a:t>Second level</a:t>
+            </a:r>
+          </a:p>
+          <a:p>
+            <a:pPr lvl="2"/>
+            <a:r>
+              <a:rPr lang="en-GB" dirty="0"/>
+              <a:t>Third level</a:t>
+            </a:r>
+          </a:p>
+          <a:p>
+            <a:pPr lvl="3"/>
+            <a:r>
+              <a:rPr lang="en-GB" dirty="0"/>
+              <a:t>Fourth level</a:t>
+            </a:r>
+          </a:p>
+          <a:p>
+            <a:pPr lvl="4"/>
+            <a:r>
+              <a:rPr lang="en-GB" dirty="0"/>
+              <a:t>Fifth level</a:t>
+            </a:r>
+            <a:endParaRPr lang="en-DE" dirty="0"/>
+          </a:p>
+        </p:txBody>
+      </p:sp>
       <p:pic>
         <p:nvPicPr>
-          <p:cNvPr id="10" name="Graphic 9">
-            <a:extLst>
-              <a:ext uri="{FF2B5EF4-FFF2-40B4-BE49-F238E27FC236}">
-                <a16:creationId xmlns:a16="http://schemas.microsoft.com/office/drawing/2014/main" id="{10003E41-C03E-3D2F-9DF2-49C04C1DA489}"/>
+          <p:cNvPr id="4" name="Picture 3">
+            <a:extLst>
+              <a:ext uri="{FF2B5EF4-FFF2-40B4-BE49-F238E27FC236}">
+                <a16:creationId xmlns:a16="http://schemas.microsoft.com/office/drawing/2014/main" id="{4D62B750-98ED-7B87-DBEE-F6F52F086B6E}"/>
               </a:ext>
             </a:extLst>
           </p:cNvPr>
@@ -7859,83 +7879,7 @@
           <p:nvPr userDrawn="1"/>
         </p:nvPicPr>
         <p:blipFill rotWithShape="1">
-          <a:blip r:embed="rId17">
-            <a:extLst>
-              <a:ext uri="{28A0092B-C50C-407E-A947-70E740481C1C}">
-                <a14:useLocalDpi xmlns:a14="http://schemas.microsoft.com/office/drawing/2010/main" val="0"/>
-              </a:ext>
-              <a:ext uri="{96DAC541-7B7A-43D3-8B79-37D633B846F1}">
-                <asvg:svgBlip xmlns:asvg="http://schemas.microsoft.com/office/drawing/2016/SVG/main" r:embed="rId18"/>
-              </a:ext>
-            </a:extLst>
-          </a:blip>
-          <a:srcRect t="-1" r="81934" b="-1"/>
-          <a:stretch/>
-        </p:blipFill>
-        <p:spPr>
-          <a:xfrm>
-            <a:off x="1873365" y="6289144"/>
-            <a:ext cx="304184" cy="267538"/>
-          </a:xfrm>
-          <a:prstGeom prst="rect">
-            <a:avLst/>
-          </a:prstGeom>
-        </p:spPr>
-      </p:pic>
-      <p:pic>
-        <p:nvPicPr>
-          <p:cNvPr id="11" name="Graphic 10">
-            <a:extLst>
-              <a:ext uri="{FF2B5EF4-FFF2-40B4-BE49-F238E27FC236}">
-                <a16:creationId xmlns:a16="http://schemas.microsoft.com/office/drawing/2014/main" id="{3FD8F14A-38B4-3140-D793-A47B962E0357}"/>
-              </a:ext>
-            </a:extLst>
-          </p:cNvPr>
-          <p:cNvPicPr>
-            <a:picLocks noChangeAspect="1"/>
-          </p:cNvPicPr>
-          <p:nvPr userDrawn="1"/>
-        </p:nvPicPr>
-        <p:blipFill rotWithShape="1">
-          <a:blip r:embed="rId17">
-            <a:extLst>
-              <a:ext uri="{28A0092B-C50C-407E-A947-70E740481C1C}">
-                <a14:useLocalDpi xmlns:a14="http://schemas.microsoft.com/office/drawing/2010/main" val="0"/>
-              </a:ext>
-              <a:ext uri="{96DAC541-7B7A-43D3-8B79-37D633B846F1}">
-                <asvg:svgBlip xmlns:asvg="http://schemas.microsoft.com/office/drawing/2016/SVG/main" r:embed="rId18"/>
-              </a:ext>
-            </a:extLst>
-          </a:blip>
-          <a:srcRect l="81992"/>
-          <a:stretch/>
-        </p:blipFill>
-        <p:spPr>
-          <a:xfrm>
-            <a:off x="2152339" y="6289144"/>
-            <a:ext cx="303202" cy="267538"/>
-          </a:xfrm>
-          <a:prstGeom prst="rect">
-            <a:avLst/>
-          </a:prstGeom>
-        </p:spPr>
-      </p:pic>
-      <p:pic>
-        <p:nvPicPr>
-          <p:cNvPr id="4" name="Picture 3">
-            <a:extLst>
-              <a:ext uri="{FF2B5EF4-FFF2-40B4-BE49-F238E27FC236}">
-                <a16:creationId xmlns:a16="http://schemas.microsoft.com/office/drawing/2014/main" id="{4D62B750-98ED-7B87-DBEE-F6F52F086B6E}"/>
-              </a:ext>
-            </a:extLst>
-          </p:cNvPr>
-          <p:cNvPicPr>
-            <a:picLocks noChangeAspect="1"/>
-          </p:cNvPicPr>
-          <p:nvPr userDrawn="1"/>
-        </p:nvPicPr>
-        <p:blipFill rotWithShape="1">
-          <a:blip r:embed="rId13">
+          <a:blip r:embed="rId14">
             <a:extLst>
               <a:ext uri="{28A0092B-C50C-407E-A947-70E740481C1C}">
                 <a14:useLocalDpi xmlns:a14="http://schemas.microsoft.com/office/drawing/2010/main" val="0"/>
@@ -8505,156 +8449,6 @@
           </a:prstGeom>
         </p:spPr>
       </p:pic>
-      <p:pic>
-        <p:nvPicPr>
-          <p:cNvPr id="6" name="Picture Placeholder 38">
-            <a:extLst>
-              <a:ext uri="{FF2B5EF4-FFF2-40B4-BE49-F238E27FC236}">
-                <a16:creationId xmlns:a16="http://schemas.microsoft.com/office/drawing/2014/main" id="{52004F97-A4A0-4DFF-4DF3-54E8888161E8}"/>
-              </a:ext>
-            </a:extLst>
-          </p:cNvPr>
-          <p:cNvPicPr>
-            <a:picLocks noChangeAspect="1"/>
-          </p:cNvPicPr>
-          <p:nvPr userDrawn="1"/>
-        </p:nvPicPr>
-        <p:blipFill rotWithShape="1">
-          <a:blip r:embed="rId14">
-            <a:extLst>
-              <a:ext uri="{28A0092B-C50C-407E-A947-70E740481C1C}">
-                <a14:useLocalDpi xmlns:a14="http://schemas.microsoft.com/office/drawing/2010/main" val="0"/>
-              </a:ext>
-            </a:extLst>
-          </a:blip>
-          <a:srcRect l="-1681" t="-16971" r="-6482" b="-29369"/>
-          <a:stretch/>
-        </p:blipFill>
-        <p:spPr>
-          <a:xfrm>
-            <a:off x="125127" y="6224400"/>
-            <a:ext cx="1786738" cy="457690"/>
-          </a:xfrm>
-          <a:prstGeom prst="rect">
-            <a:avLst/>
-          </a:prstGeom>
-        </p:spPr>
-      </p:pic>
-      <p:pic>
-        <p:nvPicPr>
-          <p:cNvPr id="12" name="Graphic 11">
-            <a:extLst>
-              <a:ext uri="{FF2B5EF4-FFF2-40B4-BE49-F238E27FC236}">
-                <a16:creationId xmlns:a16="http://schemas.microsoft.com/office/drawing/2014/main" id="{2BEAA4BE-4B8F-3EB6-6587-46177D9B4816}"/>
-              </a:ext>
-            </a:extLst>
-          </p:cNvPr>
-          <p:cNvPicPr>
-            <a:picLocks noChangeAspect="1"/>
-          </p:cNvPicPr>
-          <p:nvPr userDrawn="1"/>
-        </p:nvPicPr>
-        <p:blipFill>
-          <a:blip r:embed="rId15" cstate="print">
-            <a:extLst>
-              <a:ext uri="{28A0092B-C50C-407E-A947-70E740481C1C}">
-                <a14:useLocalDpi xmlns:a14="http://schemas.microsoft.com/office/drawing/2010/main" val="0"/>
-              </a:ext>
-              <a:ext uri="{96DAC541-7B7A-43D3-8B79-37D633B846F1}">
-                <asvg:svgBlip xmlns:asvg="http://schemas.microsoft.com/office/drawing/2016/SVG/main" r:embed="rId16"/>
-              </a:ext>
-            </a:extLst>
-          </a:blip>
-          <a:stretch>
-            <a:fillRect/>
-          </a:stretch>
-        </p:blipFill>
-        <p:spPr>
-          <a:xfrm>
-            <a:off x="2568014" y="6289144"/>
-            <a:ext cx="426729" cy="267538"/>
-          </a:xfrm>
-          <a:prstGeom prst="rect">
-            <a:avLst/>
-          </a:prstGeom>
-        </p:spPr>
-      </p:pic>
-      <p:pic>
-        <p:nvPicPr>
-          <p:cNvPr id="13" name="Graphic 12">
-            <a:extLst>
-              <a:ext uri="{FF2B5EF4-FFF2-40B4-BE49-F238E27FC236}">
-                <a16:creationId xmlns:a16="http://schemas.microsoft.com/office/drawing/2014/main" id="{B8BA9CCA-EF0A-3373-8013-3B977D0641E9}"/>
-              </a:ext>
-            </a:extLst>
-          </p:cNvPr>
-          <p:cNvPicPr>
-            <a:picLocks noChangeAspect="1"/>
-          </p:cNvPicPr>
-          <p:nvPr userDrawn="1"/>
-        </p:nvPicPr>
-        <p:blipFill rotWithShape="1">
-          <a:blip r:embed="rId17">
-            <a:extLst>
-              <a:ext uri="{28A0092B-C50C-407E-A947-70E740481C1C}">
-                <a14:useLocalDpi xmlns:a14="http://schemas.microsoft.com/office/drawing/2010/main" val="0"/>
-              </a:ext>
-              <a:ext uri="{96DAC541-7B7A-43D3-8B79-37D633B846F1}">
-                <asvg:svgBlip xmlns:asvg="http://schemas.microsoft.com/office/drawing/2016/SVG/main" r:embed="rId18"/>
-              </a:ext>
-            </a:extLst>
-          </a:blip>
-          <a:srcRect t="-1" r="81934" b="-1"/>
-          <a:stretch/>
-        </p:blipFill>
-        <p:spPr>
-          <a:xfrm>
-            <a:off x="1873365" y="6289144"/>
-            <a:ext cx="304184" cy="267538"/>
-          </a:xfrm>
-          <a:prstGeom prst="rect">
-            <a:avLst/>
-          </a:prstGeom>
-        </p:spPr>
-      </p:pic>
-      <p:pic>
-        <p:nvPicPr>
-          <p:cNvPr id="14" name="Graphic 13">
-            <a:extLst>
-              <a:ext uri="{FF2B5EF4-FFF2-40B4-BE49-F238E27FC236}">
-                <a16:creationId xmlns:a16="http://schemas.microsoft.com/office/drawing/2014/main" id="{CC81AD36-35A0-1697-5C70-8FF530130EB5}"/>
-              </a:ext>
-            </a:extLst>
-          </p:cNvPr>
-          <p:cNvPicPr>
-            <a:picLocks noChangeAspect="1"/>
-          </p:cNvPicPr>
-          <p:nvPr userDrawn="1"/>
-        </p:nvPicPr>
-        <p:blipFill rotWithShape="1">
-          <a:blip r:embed="rId17">
-            <a:extLst>
-              <a:ext uri="{28A0092B-C50C-407E-A947-70E740481C1C}">
-                <a14:useLocalDpi xmlns:a14="http://schemas.microsoft.com/office/drawing/2010/main" val="0"/>
-              </a:ext>
-              <a:ext uri="{96DAC541-7B7A-43D3-8B79-37D633B846F1}">
-                <asvg:svgBlip xmlns:asvg="http://schemas.microsoft.com/office/drawing/2016/SVG/main" r:embed="rId18"/>
-              </a:ext>
-            </a:extLst>
-          </a:blip>
-          <a:srcRect l="81992"/>
-          <a:stretch/>
-        </p:blipFill>
-        <p:spPr>
-          <a:xfrm>
-            <a:off x="2152339" y="6289144"/>
-            <a:ext cx="303202" cy="267538"/>
-          </a:xfrm>
-          <a:prstGeom prst="rect">
-            <a:avLst/>
-          </a:prstGeom>
-        </p:spPr>
-      </p:pic>
       <p:sp>
         <p:nvSpPr>
           <p:cNvPr id="17" name="Slide Number Placeholder 16">
@@ -8703,6 +8497,42 @@
           </a:p>
         </p:txBody>
       </p:sp>
+      <p:pic>
+        <p:nvPicPr>
+          <p:cNvPr id="5" name="Grafik 4" descr="Ein Bild, das Screenshot, Kreis, Schrift enthält.&#10;&#10;Automatisch generierte Beschreibung">
+            <a:extLst>
+              <a:ext uri="{FF2B5EF4-FFF2-40B4-BE49-F238E27FC236}">
+                <a16:creationId xmlns:a16="http://schemas.microsoft.com/office/drawing/2014/main" id="{AFC5E93D-914A-FF3E-A38C-1551D38A6EE4}"/>
+              </a:ext>
+            </a:extLst>
+          </p:cNvPr>
+          <p:cNvPicPr>
+            <a:picLocks noChangeAspect="1"/>
+          </p:cNvPicPr>
+          <p:nvPr userDrawn="1"/>
+        </p:nvPicPr>
+        <p:blipFill>
+          <a:blip r:embed="rId14">
+            <a:extLst>
+              <a:ext uri="{28A0092B-C50C-407E-A947-70E740481C1C}">
+                <a14:useLocalDpi xmlns:a14="http://schemas.microsoft.com/office/drawing/2010/main" val="0"/>
+              </a:ext>
+            </a:extLst>
+          </a:blip>
+          <a:stretch>
+            <a:fillRect/>
+          </a:stretch>
+        </p:blipFill>
+        <p:spPr>
+          <a:xfrm>
+            <a:off x="154188" y="6278791"/>
+            <a:ext cx="1647015" cy="311840"/>
+          </a:xfrm>
+          <a:prstGeom prst="rect">
+            <a:avLst/>
+          </a:prstGeom>
+        </p:spPr>
+      </p:pic>
     </p:spTree>
     <p:extLst>
       <p:ext uri="{BB962C8B-B14F-4D97-AF65-F5344CB8AC3E}">

</xml_diff>